<commit_message>
notes: deck gains the pair-robustness result; generator committed to the repo
The Israel slide gets a fourth fact card — against the TR-parallel pair the
primary correlates at r = 0.96 in levels and 0.89 in annual changes over
162 common months, same trough, same calm — and the reproducibility slide
records data/cattle-il-alt.json. The deck is now regenerable from the repo
(scripts/deck_data.py precomputes every quoted figure from data/*.json,
scripts/gen_parity_deck.js renders the slides), and the headline percent
tiles are computed rather than typed, so the deck can no longer drift from
the data — this rebuild already picked up EU moving from +20% to +22%.

Co-Authored-By: Claude Opus 5 <noreply@anthropic.com>
Claude-Session: https://claude.ai/code/session_01E8nbLQcWtiRd3PVZmv3HNz
</commit_message>
<xml_diff>
--- a/notes/cattle-parity-four-markets.pptx
+++ b/notes/cattle-parity-four-markets.pptx
@@ -1103,7 +1103,7 @@
                   <c:v>134.9</c:v>
                 </c:pt>
                 <c:pt idx="66">
-                  <c:v>120.8</c:v>
+                  <c:v>121.9</c:v>
                 </c:pt>
               </c:numCache>
             </c:numRef>
@@ -5450,7 +5450,7 @@
           <a:p>
             <a:r>
               <a:rPr lang="en-US" dirty="0"/>
-              <a:t>Why Israel and not others: it is the only Middle East market publishing both sides monthly, machine-readably, from one office. The 2023 trough is the grain crisis, same as everywhere.</a:t>
+              <a:t>Why Israel and not others: only Middle East market publishing both sides monthly, machine-readably, from one office. If asked why beef-vs-fodder: the TR-parallel pair gives the same answer, r = 0.96.</a:t>
             </a:r>
             <a:endParaRPr lang="en-US" dirty="0"/>
           </a:p>
@@ -6524,7 +6524,7 @@
                 <a:ea typeface="Arial" pitchFamily="34" charset="-122"/>
                 <a:cs typeface="Arial" pitchFamily="34" charset="-120"/>
               </a:rPr>
-              <a:t>1,252</a:t>
+              <a:t>1,255</a:t>
             </a:r>
             <a:pPr indent="0" marL="0">
               <a:buNone/>
@@ -6913,7 +6913,7 @@
                 <a:ea typeface="Arial" pitchFamily="34" charset="-122"/>
                 <a:cs typeface="Arial" pitchFamily="34" charset="-120"/>
               </a:rPr>
-              <a:t>series measure different objects (live cattle / carcass / processed meat; corn / feed grain / compound feed / fodder) — changes are compared, never levels. Spans differ (55y / 11y / 16y / 21y). Israel's raw feed has rebasing cliffs; we chain and verify (2020 mean = 100 both sides). Saudi Arabia is declared missing, not silently dropped.
+              <a:t>series measure different objects (live cattle / carcass / processed meat; corn / feed grain / compound feed / fodder) — changes are compared, never levels. Spans differ. Israel's raw feed has rebasing cliffs; we chain and verify (2020 mean = 100 both sides). Israel's pair choice is robustness-checked against the TR-parallel pair (r = 0.96; data/cattle-il-alt.json). Saudi Arabia is declared missing, not silently dropped.
 </a:t>
             </a:r>
             <a:pPr indent="0" marL="0">
@@ -6942,7 +6942,7 @@
                 <a:ea typeface="Arial" pitchFamily="34" charset="-122"/>
                 <a:cs typeface="Arial" pitchFamily="34" charset="-120"/>
               </a:rPr>
-              <a:t>github.com/namikakmandev/namikakmandev.github.io — data/cattle-*.json, scripts/fetch_cattle_data.py, refreshed monthly by GitHub Actions. Interactive version: namikakman.dev/parite-sigir.html · methodology: /parite-sigir-metodoloji.html. Data cut-off: Aug 2026.</a:t>
+              <a:t>github.com/namikakmandev/namikakmandev.github.io — data/cattle-*.json, scripts/fetch_cattle_data.py, refreshed monthly by GitHub Actions (cron, 3rd of month). Deck regenerable: scripts/deck_data.py + scripts/gen_parity_deck.js. Interactive version: namikakman.dev/parite-sigir.html · methodology: /parite-sigir-metodoloji.html. Data cut-off: Aug 2026.</a:t>
             </a:r>
             <a:endParaRPr lang="en-US" sz="1150" dirty="0"/>
           </a:p>
@@ -8981,7 +8981,7 @@
                 <a:ea typeface="Arial" pitchFamily="34" charset="-122"/>
                 <a:cs typeface="Arial" pitchFamily="34" charset="-120"/>
               </a:rPr>
-              <a:t>+20%</a:t>
+              <a:t>+22%</a:t>
             </a:r>
             <a:pPr indent="0" marL="0">
               <a:buNone/>
@@ -9171,7 +9171,7 @@
                 <a:ea typeface="Arial" pitchFamily="34" charset="-122"/>
                 <a:cs typeface="Arial" pitchFamily="34" charset="-120"/>
               </a:rPr>
-              <a:t>-16%</a:t>
+              <a:t>−16%</a:t>
             </a:r>
             <a:pPr indent="0" marL="0">
               <a:buNone/>
@@ -9224,7 +9224,7 @@
                 <a:ea typeface="Courier New" pitchFamily="34" charset="-122"/>
                 <a:cs typeface="Courier New" pitchFamily="34" charset="-120"/>
               </a:rPr>
-              <a:t>QUARTERLY MEANS OF MONTHLY PARITY, EACH SERIES ÷ ITS OWN 2016 MEAN × 100 · JUN–AUG 2026 LATEST · SOURCES AS ON SLIDE 2</a:t>
+              <a:t>QUARTERLY MEANS OF MONTHLY PARITY, EACH SERIES ÷ ITS OWN 2016 MEAN × 100 · SOURCES AS ON SLIDE 2</a:t>
             </a:r>
             <a:endParaRPr lang="en-US" sz="850" dirty="0"/>
           </a:p>
@@ -9920,8 +9920,8 @@
         </p:nvSpPr>
         <p:spPr>
           <a:xfrm>
-            <a:off x="8183880" y="1645920"/>
-            <a:ext cx="3474720" cy="1371600"/>
+            <a:off x="8183880" y="1554480"/>
+            <a:ext cx="3474720" cy="1115568"/>
           </a:xfrm>
           <a:prstGeom prst="rect">
             <a:avLst/>
@@ -9952,7 +9952,7 @@
               <a:buNone/>
             </a:pPr>
             <a:r>
-              <a:rPr lang="en-US" sz="1100" dirty="0">
+              <a:rPr lang="en-US" sz="1000" dirty="0">
                 <a:solidFill>
                   <a:srgbClr val="CBBFA8"/>
                 </a:solidFill>
@@ -9974,8 +9974,8 @@
         </p:nvSpPr>
         <p:spPr>
           <a:xfrm>
-            <a:off x="8183880" y="3127248"/>
-            <a:ext cx="3474720" cy="1371600"/>
+            <a:off x="8183880" y="2724912"/>
+            <a:ext cx="3474720" cy="1115568"/>
           </a:xfrm>
           <a:prstGeom prst="rect">
             <a:avLst/>
@@ -10006,7 +10006,7 @@
               <a:buNone/>
             </a:pPr>
             <a:r>
-              <a:rPr lang="en-US" sz="1100" dirty="0">
+              <a:rPr lang="en-US" sz="1000" dirty="0">
                 <a:solidFill>
                   <a:srgbClr val="CBBFA8"/>
                 </a:solidFill>
@@ -10028,8 +10028,8 @@
         </p:nvSpPr>
         <p:spPr>
           <a:xfrm>
-            <a:off x="8183880" y="4608576"/>
-            <a:ext cx="3474720" cy="1371600"/>
+            <a:off x="8183880" y="3895344"/>
+            <a:ext cx="3474720" cy="1115568"/>
           </a:xfrm>
           <a:prstGeom prst="rect">
             <a:avLst/>
@@ -10060,7 +10060,7 @@
               <a:buNone/>
             </a:pPr>
             <a:r>
-              <a:rPr lang="en-US" sz="1100" dirty="0">
+              <a:rPr lang="en-US" sz="1000" dirty="0">
                 <a:solidFill>
                   <a:srgbClr val="CBBFA8"/>
                 </a:solidFill>
@@ -10077,6 +10077,60 @@
       <p:sp>
         <p:nvSpPr>
           <p:cNvPr id="8" name="Text 5"/>
+          <p:cNvSpPr/>
+          <p:nvPr/>
+        </p:nvSpPr>
+        <p:spPr>
+          <a:xfrm>
+            <a:off x="8183880" y="5065776"/>
+            <a:ext cx="3474720" cy="1115568"/>
+          </a:xfrm>
+          <a:prstGeom prst="rect">
+            <a:avLst/>
+          </a:prstGeom>
+          <a:noFill/>
+          <a:ln/>
+        </p:spPr>
+        <p:txBody>
+          <a:bodyPr wrap="square" lIns="0" tIns="0" rIns="0" bIns="0" rtlCol="0" anchor="ctr"/>
+          <a:lstStyle/>
+          <a:p>
+            <a:pPr indent="0" marL="0">
+              <a:buNone/>
+            </a:pPr>
+            <a:r>
+              <a:rPr lang="en-US" sz="950" b="1" dirty="0">
+                <a:solidFill>
+                  <a:srgbClr val="46C8B2"/>
+                </a:solidFill>
+                <a:latin typeface="Courier New" pitchFamily="34" charset="0"/>
+                <a:ea typeface="Courier New" pitchFamily="34" charset="-122"/>
+                <a:cs typeface="Courier New" pitchFamily="34" charset="-120"/>
+              </a:rPr>
+              <a:t>PAIR ROBUSTNESS
+</a:t>
+            </a:r>
+            <a:pPr indent="0" marL="0">
+              <a:buNone/>
+            </a:pPr>
+            <a:r>
+              <a:rPr lang="en-US" sz="1000" dirty="0">
+                <a:solidFill>
+                  <a:srgbClr val="CBBFA8"/>
+                </a:solidFill>
+                <a:latin typeface="Arial" pitchFamily="34" charset="0"/>
+                <a:ea typeface="Arial" pitchFamily="34" charset="-122"/>
+                <a:cs typeface="Arial" pitchFamily="34" charset="-120"/>
+              </a:rPr>
+              <a:t>Against the exact TR-parallel pair (meat processing ÷ prepared feeds): r = 0.96 in levels, 0.89 in annual changes over 162 common months — same trough, same calm. The conclusion does not depend on the pair chosen.</a:t>
+            </a:r>
+            <a:endParaRPr lang="en-US" sz="950" dirty="0"/>
+          </a:p>
+        </p:txBody>
+      </p:sp>
+      <p:sp>
+        <p:nvSpPr>
+          <p:cNvPr id="9" name="Text 6"/>
           <p:cNvSpPr/>
           <p:nvPr/>
         </p:nvSpPr>
@@ -10107,7 +10161,7 @@
                 <a:ea typeface="Courier New" pitchFamily="34" charset="-122"/>
                 <a:cs typeface="Courier New" pitchFamily="34" charset="-120"/>
               </a:rPr>
-              <a:t>ISRAEL CBS INDEX API · CODES 190030 / 260030 · 259 MONTHS · BASE-CHAINED ACROSS CBS REBASINGS (SLIDE 2) · INDEX: OWN 2016 MEAN = 100</a:t>
+              <a:t>ISRAEL CBS INDEX API · CODES 190030 / 260030 · BASE-CHAINED (SLIDE 2) · ROBUSTNESS PAIR 180073 / 180195 · INDEX: OWN 2016 MEAN = 100</a:t>
             </a:r>
             <a:endParaRPr lang="en-US" sz="850" dirty="0"/>
           </a:p>
@@ -11105,7 +11159,7 @@
                 <a:ea typeface="Arial" pitchFamily="34" charset="-122"/>
                 <a:cs typeface="Arial" pitchFamily="34" charset="-120"/>
               </a:rPr>
-              <a:t>Record territory. Peaked Aug 2025 at 2.54; still 2.44 — deepest herd liquidation in decades keeps meat dear while corn is cheap.</a:t>
+              <a:t>Record territory. Peaked Aug 2025 at 2.54; deepest herd liquidation in decades keeps meat dear while corn is cheap.</a:t>
             </a:r>
             <a:endParaRPr lang="en-US" sz="1050" dirty="0"/>
           </a:p>
@@ -11210,7 +11264,7 @@
                 <a:ea typeface="Arial" pitchFamily="34" charset="-122"/>
                 <a:cs typeface="Arial" pitchFamily="34" charset="-120"/>
               </a:rPr>
-              <a:t>+20%</a:t>
+              <a:t>+22%</a:t>
             </a:r>
             <a:endParaRPr lang="en-US" sz="4000" dirty="0"/>
           </a:p>
@@ -11693,7 +11747,7 @@
                 <a:ea typeface="Courier New" pitchFamily="34" charset="-122"/>
                 <a:cs typeface="Courier New" pitchFamily="34" charset="-120"/>
               </a:rPr>
-              <a:t>INDEX = LATEST MONTHLY PARITY ÷ OWN 2016 MEAN · US &amp; TR JUL 2026 · EU AUG 2026 · IL JUL 2026</a:t>
+              <a:t>INDEX = LATEST MONTHLY PARITY ÷ OWN 2016 MEAN · LATEST: US 2026-07 · EU 2026-08 · TR 2026-07 · IL 2026-07</a:t>
             </a:r>
             <a:endParaRPr lang="en-US" sz="850" dirty="0"/>
           </a:p>

</xml_diff>